<commit_message>
Simplify Friday PLC feedback routine
Make Step 4 a clear three-part feedback routine: say what is missing, where to look, and what to revise.
</commit_message>
<xml_diff>
--- a/assets/plc/2026-10-30_Lesson_Internalization_Use_Student_Work_to_Adjust_Next_Learning_Experience.pptx
+++ b/assets/plc/2026-10-30_Lesson_Internalization_Use_Student_Work_to_Adjust_Next_Learning_Experience.pptx
@@ -5410,7 +5410,7 @@
                 <a:ea typeface="Inter" pitchFamily="34" charset="-122"/>
                 <a:cs typeface="Inter" pitchFamily="34" charset="-120"/>
               </a:rPr>
-              <a:t>Step 4: Write Feedback Students Can Use</a:t>
+              <a:t>Step 4: Give Clear Feedback</a:t>
             </a:r>
             <a:endParaRPr lang="en-US" sz="3000" dirty="0"/>
           </a:p>
@@ -5488,7 +5488,7 @@
                 <a:ea typeface="Inter" pitchFamily="34" charset="-122"/>
                 <a:cs typeface="Inter" pitchFamily="34" charset="-120"/>
               </a:rPr>
-              <a:t>Write one short comment on the sample. It should send the student back to the rubric and back to their own writing.</a:t>
+              <a:t>Write one short comment. Tell the student what is missing, where to look, and what to do next.</a:t>
             </a:r>
             <a:endParaRPr lang="en-US" sz="2200" dirty="0"/>
           </a:p>
@@ -5552,7 +5552,7 @@
                 <a:ea typeface="Inter" pitchFamily="34" charset="-122"/>
                 <a:cs typeface="Inter" pitchFamily="34" charset="-120"/>
               </a:rPr>
-              <a:t>1. Name the criterion</a:t>
+              <a:t>1. Say what is missing</a:t>
             </a:r>
             <a:endParaRPr lang="en-US" sz="2400" dirty="0"/>
           </a:p>
@@ -5566,8 +5566,8 @@
         </p:nvSpPr>
         <p:spPr>
           <a:xfrm>
-            <a:off x="889000" y="3378200"/>
-            <a:ext cx="4191000" cy="1346200"/>
+            <a:off x="889000" y="3352800"/>
+            <a:ext cx="4191000" cy="1320800"/>
           </a:xfrm>
           <a:prstGeom prst="rect">
             <a:avLst/>
@@ -5594,7 +5594,7 @@
                 <a:ea typeface="Inter" pitchFamily="34" charset="-122"/>
                 <a:cs typeface="Inter" pitchFamily="34" charset="-120"/>
               </a:rPr>
-              <a:t>Say which rubric criterion the comment is about.</a:t>
+              <a:t>Use the rubric word. Name the part of the response that needs work.</a:t>
             </a:r>
             <a:endParaRPr lang="en-US" sz="2000" dirty="0"/>
           </a:p>
@@ -5609,7 +5609,7 @@
         <p:spPr>
           <a:xfrm>
             <a:off x="889000" y="4851400"/>
-            <a:ext cx="4191000" cy="1524000"/>
+            <a:ext cx="4191000" cy="1498600"/>
           </a:xfrm>
           <a:prstGeom prst="rect">
             <a:avLst/>
@@ -5659,7 +5659,7 @@
                 <a:ea typeface="Inter" pitchFamily="34" charset="-122"/>
                 <a:cs typeface="Inter" pitchFamily="34" charset="-120"/>
               </a:rPr>
-              <a:t>“This is your claim, and it is clear.”</a:t>
+              <a:t>“Your reasoning is missing.”</a:t>
             </a:r>
             <a:endParaRPr lang="en-US" sz="1900" dirty="0"/>
           </a:p>
@@ -5723,7 +5723,7 @@
                 <a:ea typeface="Inter" pitchFamily="34" charset="-122"/>
                 <a:cs typeface="Inter" pitchFamily="34" charset="-120"/>
               </a:rPr>
-              <a:t>2. Point to their work</a:t>
+              <a:t>2. Tell them where to look</a:t>
             </a:r>
             <a:endParaRPr lang="en-US" sz="2400" dirty="0"/>
           </a:p>
@@ -5737,8 +5737,8 @@
         </p:nvSpPr>
         <p:spPr>
           <a:xfrm>
-            <a:off x="6057900" y="3378200"/>
-            <a:ext cx="4191000" cy="1346200"/>
+            <a:off x="6057900" y="3352800"/>
+            <a:ext cx="4191000" cy="1320800"/>
           </a:xfrm>
           <a:prstGeom prst="rect">
             <a:avLst/>
@@ -5765,7 +5765,7 @@
                 <a:ea typeface="Inter" pitchFamily="34" charset="-122"/>
                 <a:cs typeface="Inter" pitchFamily="34" charset="-120"/>
               </a:rPr>
-              <a:t>Quote or point to the student's own words, graph detail, or food-web arrow.</a:t>
+              <a:t>Point students to their writing, graph, model, article, or data table.</a:t>
             </a:r>
             <a:endParaRPr lang="en-US" sz="2000" dirty="0"/>
           </a:p>
@@ -5780,7 +5780,7 @@
         <p:spPr>
           <a:xfrm>
             <a:off x="6057900" y="4851400"/>
-            <a:ext cx="4191000" cy="1524000"/>
+            <a:ext cx="4191000" cy="1498600"/>
           </a:xfrm>
           <a:prstGeom prst="rect">
             <a:avLst/>
@@ -5830,7 +5830,7 @@
                 <a:ea typeface="Inter" pitchFamily="34" charset="-122"/>
                 <a:cs typeface="Inter" pitchFamily="34" charset="-120"/>
               </a:rPr>
-              <a:t>“You wrote that frogs eat fruit flies.”</a:t>
+              <a:t>“Look at the graph and food web you used.”</a:t>
             </a:r>
             <a:endParaRPr lang="en-US" sz="1900" dirty="0"/>
           </a:p>
@@ -5894,7 +5894,7 @@
                 <a:ea typeface="Inter" pitchFamily="34" charset="-122"/>
                 <a:cs typeface="Inter" pitchFamily="34" charset="-120"/>
               </a:rPr>
-              <a:t>3. Ask for one revision</a:t>
+              <a:t>3. Tell them what to do</a:t>
             </a:r>
             <a:endParaRPr lang="en-US" sz="2400" dirty="0"/>
           </a:p>
@@ -5908,8 +5908,8 @@
         </p:nvSpPr>
         <p:spPr>
           <a:xfrm>
-            <a:off x="11226800" y="3378200"/>
-            <a:ext cx="4191000" cy="1346200"/>
+            <a:off x="11226800" y="3352800"/>
+            <a:ext cx="4191000" cy="1320800"/>
           </a:xfrm>
           <a:prstGeom prst="rect">
             <a:avLst/>
@@ -5936,7 +5936,7 @@
                 <a:ea typeface="Inter" pitchFamily="34" charset="-122"/>
                 <a:cs typeface="Inter" pitchFamily="34" charset="-120"/>
               </a:rPr>
-              <a:t>Ask for one change the student can make. Do not give the answer or write it for them.</a:t>
+              <a:t>Ask for one clear revision. Do not give the answer or write it for them.</a:t>
             </a:r>
             <a:endParaRPr lang="en-US" sz="2000" dirty="0"/>
           </a:p>
@@ -5951,7 +5951,7 @@
         <p:spPr>
           <a:xfrm>
             <a:off x="11226800" y="4851400"/>
-            <a:ext cx="4191000" cy="1524000"/>
+            <a:ext cx="4191000" cy="1498600"/>
           </a:xfrm>
           <a:prstGeom prst="rect">
             <a:avLst/>
@@ -6001,7 +6001,7 @@
                 <a:ea typeface="Inter" pitchFamily="34" charset="-122"/>
                 <a:cs typeface="Inter" pitchFamily="34" charset="-120"/>
               </a:rPr>
-              <a:t>“Now explain how that makes the fruit-fly population drop.”</a:t>
+              <a:t>“Add one sentence that explains how the evidence supports your claim.”</a:t>
             </a:r>
             <a:endParaRPr lang="en-US" sz="1900" dirty="0"/>
           </a:p>
@@ -6035,24 +6035,24 @@
         </p:nvSpPr>
         <p:spPr>
           <a:xfrm>
-            <a:off x="812800" y="7213600"/>
-            <a:ext cx="14605000" cy="304800"/>
-          </a:xfrm>
-          <a:prstGeom prst="rect">
-            <a:avLst/>
-          </a:prstGeom>
-          <a:noFill/>
-          <a:ln/>
-        </p:spPr>
-        <p:txBody>
-          <a:bodyPr wrap="square" lIns="0" tIns="0" rIns="0" bIns="0" rtlCol="0" anchor="t"/>
-          <a:lstStyle/>
-          <a:p>
-            <a:pPr algn="l" indent="0" marL="0">
-              <a:buNone/>
-            </a:pPr>
-            <a:r>
-              <a:rPr lang="en-US" altLang="en-US" sz="2000" b="1" dirty="0">
+            <a:off x="812800" y="7188200"/>
+            <a:ext cx="14605000" cy="330200"/>
+          </a:xfrm>
+          <a:prstGeom prst="rect">
+            <a:avLst/>
+          </a:prstGeom>
+          <a:noFill/>
+          <a:ln/>
+        </p:spPr>
+        <p:txBody>
+          <a:bodyPr wrap="square" lIns="0" tIns="0" rIns="0" bIns="0" rtlCol="0" anchor="t"/>
+          <a:lstStyle/>
+          <a:p>
+            <a:pPr algn="l" indent="0" marL="0">
+              <a:buNone/>
+            </a:pPr>
+            <a:r>
+              <a:rPr lang="en-US" altLang="en-US" sz="1900" b="1" dirty="0">
                 <a:solidFill>
                   <a:srgbClr val="F6B4BA"/>
                 </a:solidFill>
@@ -6060,10 +6060,10 @@
                 <a:ea typeface="Inter" pitchFamily="34" charset="-122"/>
                 <a:cs typeface="Inter" pitchFamily="34" charset="-120"/>
               </a:rPr>
-              <a:t>Check:</a:t>
-            </a:r>
-            <a:r>
-              <a:rPr lang="en-US" altLang="en-US" sz="2000" dirty="0">
+              <a:t>Use this frame:</a:t>
+            </a:r>
+            <a:r>
+              <a:rPr lang="en-US" altLang="en-US" sz="1900" dirty="0">
                 <a:solidFill>
                   <a:srgbClr val="FFFFFF"/>
                 </a:solidFill>
@@ -6071,9 +6071,9 @@
                 <a:ea typeface="Inter" pitchFamily="34" charset="-122"/>
                 <a:cs typeface="Inter" pitchFamily="34" charset="-120"/>
               </a:rPr>
-              <a:t> does the comment name a criterion, point to the work, and ask for one action?</a:t>
-            </a:r>
-            <a:endParaRPr lang="en-US" sz="2000" dirty="0"/>
+              <a:t> “You need to ______. Look at ______. Add or revise ______.”</a:t>
+            </a:r>
+            <a:endParaRPr lang="en-US" sz="1900" dirty="0"/>
           </a:p>
         </p:txBody>
       </p:sp>

</xml_diff>